<commit_message>
feat(sesi-06): upgrade capacitor android & usb debugging modules to pedagogical standard
</commit_message>
<xml_diff>
--- a/slide_presentasi/SESI_06_Capacitor_Bridge_dan_Android_Studio.pptx
+++ b/slide_presentasi/SESI_06_Capacitor_Bridge_dan_Android_Studio.pptx
@@ -3156,8 +3156,8 @@
         </p:nvSpPr>
         <p:spPr>
           <a:xfrm>
-            <a:off x="896112" y="896112"/>
-            <a:ext cx="10545775" cy="5212080"/>
+            <a:off x="896112" y="530352"/>
+            <a:ext cx="10545775" cy="5897880"/>
           </a:xfrm>
           <a:prstGeom prst="rect">
             <a:avLst/>
@@ -3199,8 +3199,8 @@
         </p:nvSpPr>
         <p:spPr>
           <a:xfrm>
-            <a:off x="822960" y="822960"/>
-            <a:ext cx="10545775" cy="5212080"/>
+            <a:off x="822960" y="457200"/>
+            <a:ext cx="10545775" cy="5897880"/>
           </a:xfrm>
           <a:prstGeom prst="rect">
             <a:avLst/>
@@ -3244,8 +3244,8 @@
         </p:nvSpPr>
         <p:spPr>
           <a:xfrm>
-            <a:off x="1280160" y="1188720"/>
-            <a:ext cx="9601200" cy="4389120"/>
+            <a:off x="1097280" y="594360"/>
+            <a:ext cx="9997135" cy="1371600"/>
           </a:xfrm>
           <a:prstGeom prst="rect">
             <a:avLst/>
@@ -3260,9 +3260,9 @@
           <a:p>
             <a:pPr>
               <a:spcAft>
-                <a:spcPts val="1600"/>
+                <a:spcPts val="400"/>
               </a:spcAft>
-              <a:defRPr sz="1200" b="1">
+              <a:defRPr sz="1100" b="1">
                 <a:solidFill>
                   <a:srgbClr val="000000"/>
                 </a:solidFill>
@@ -3276,9 +3276,9 @@
           <a:p>
             <a:pPr>
               <a:spcAft>
-                <a:spcPts val="1400"/>
+                <a:spcPts val="400"/>
               </a:spcAft>
-              <a:defRPr sz="2600" b="1">
+              <a:defRPr sz="2200" b="1">
                 <a:solidFill>
                   <a:srgbClr val="000000"/>
                 </a:solidFill>
@@ -3291,35 +3291,543 @@
           </a:p>
           <a:p>
             <a:pPr>
+              <a:defRPr sz="1050">
+                <a:solidFill>
+                  <a:srgbClr val="464646"/>
+                </a:solidFill>
+                <a:latin typeface="Segoe UI"/>
+              </a:defRPr>
+            </a:pPr>
+            <a:r>
+              <a:t>Mata Kuliah: Pemrograman Berbasis Perangkat Bergerak (STSI4303 / MSIM4401)</a:t>
+            </a:r>
+            <a:br/>
+            <a:r>
+              <a:t>Modul Acuan BMP: Modul 6 &amp; 7 • Arsitektur Jembatan, Konfigurasi Gradle, Runtime Permissions &amp; Solusi RAM 4–8GB</a:t>
+            </a:r>
+          </a:p>
+        </p:txBody>
+      </p:sp>
+      <p:sp>
+        <p:nvSpPr>
+          <p:cNvPr id="6" name="Rectangle 5"/>
+          <p:cNvSpPr/>
+          <p:nvPr/>
+        </p:nvSpPr>
+        <p:spPr>
+          <a:xfrm>
+            <a:off x="1170432" y="2130552"/>
+            <a:ext cx="4864608" cy="2468880"/>
+          </a:xfrm>
+          <a:prstGeom prst="rect">
+            <a:avLst/>
+          </a:prstGeom>
+          <a:solidFill>
+            <a:srgbClr val="000000"/>
+          </a:solidFill>
+          <a:ln>
+            <a:noFill/>
+          </a:ln>
+        </p:spPr>
+        <p:style>
+          <a:lnRef idx="1">
+            <a:schemeClr val="accent1"/>
+          </a:lnRef>
+          <a:fillRef idx="3">
+            <a:schemeClr val="accent1"/>
+          </a:fillRef>
+          <a:effectRef idx="2">
+            <a:schemeClr val="accent1"/>
+          </a:effectRef>
+          <a:fontRef idx="minor">
+            <a:schemeClr val="lt1"/>
+          </a:fontRef>
+        </p:style>
+        <p:txBody>
+          <a:bodyPr rtlCol="0" anchor="ctr"/>
+          <a:lstStyle/>
+          <a:p>
+            <a:pPr algn="ctr"/>
+          </a:p>
+        </p:txBody>
+      </p:sp>
+      <p:sp>
+        <p:nvSpPr>
+          <p:cNvPr id="7" name="Rectangle 6"/>
+          <p:cNvSpPr/>
+          <p:nvPr/>
+        </p:nvSpPr>
+        <p:spPr>
+          <a:xfrm>
+            <a:off x="1097280" y="2057400"/>
+            <a:ext cx="4864608" cy="2468880"/>
+          </a:xfrm>
+          <a:prstGeom prst="rect">
+            <a:avLst/>
+          </a:prstGeom>
+          <a:solidFill>
+            <a:srgbClr val="F5F3FF"/>
+          </a:solidFill>
+          <a:ln w="31750">
+            <a:solidFill>
+              <a:srgbClr val="000000"/>
+            </a:solidFill>
+          </a:ln>
+        </p:spPr>
+        <p:style>
+          <a:lnRef idx="1">
+            <a:schemeClr val="accent1"/>
+          </a:lnRef>
+          <a:fillRef idx="3">
+            <a:schemeClr val="accent1"/>
+          </a:fillRef>
+          <a:effectRef idx="2">
+            <a:schemeClr val="accent1"/>
+          </a:effectRef>
+          <a:fontRef idx="minor">
+            <a:schemeClr val="lt1"/>
+          </a:fontRef>
+        </p:style>
+        <p:txBody>
+          <a:bodyPr rtlCol="0" anchor="ctr"/>
+          <a:lstStyle/>
+          <a:p>
+            <a:pPr algn="ctr"/>
+          </a:p>
+        </p:txBody>
+      </p:sp>
+      <p:sp>
+        <p:nvSpPr>
+          <p:cNvPr id="8" name="TextBox 7"/>
+          <p:cNvSpPr txBox="1"/>
+          <p:nvPr/>
+        </p:nvSpPr>
+        <p:spPr>
+          <a:xfrm>
+            <a:off x="1280160" y="2194560"/>
+            <a:ext cx="4498848" cy="2194560"/>
+          </a:xfrm>
+          <a:prstGeom prst="rect">
+            <a:avLst/>
+          </a:prstGeom>
+          <a:noFill/>
+        </p:spPr>
+        <p:txBody>
+          <a:bodyPr wrap="square">
+            <a:spAutoFit/>
+          </a:bodyPr>
+          <a:lstStyle/>
+          <a:p>
+            <a:pPr>
               <a:spcAft>
-                <a:spcPts val="3600"/>
+                <a:spcPts val="600"/>
               </a:spcAft>
-              <a:defRPr sz="1350">
+              <a:defRPr sz="1100" b="1">
+                <a:solidFill>
+                  <a:srgbClr val="581C87"/>
+                </a:solidFill>
+                <a:latin typeface="Segoe UI"/>
+              </a:defRPr>
+            </a:pPr>
+            <a:r>
+              <a:t>🎯 PETA KURIKULUM &amp; TARGET KOMPETENSI</a:t>
+            </a:r>
+          </a:p>
+          <a:p>
+            <a:pPr>
+              <a:spcAft>
+                <a:spcPts val="400"/>
+              </a:spcAft>
+              <a:defRPr sz="950">
+                <a:solidFill>
+                  <a:srgbClr val="1E1E1E"/>
+                </a:solidFill>
+                <a:latin typeface="Segoe UI"/>
+              </a:defRPr>
+            </a:pPr>
+            <a:r>
+              <a:t>■  Transisi ke Native: Melangkah dari Sandbox Web menuju Ekosistem Android OS.</a:t>
+            </a:r>
+          </a:p>
+          <a:p>
+            <a:pPr>
+              <a:spcAft>
+                <a:spcPts val="400"/>
+              </a:spcAft>
+              <a:defRPr sz="950">
+                <a:solidFill>
+                  <a:srgbClr val="1E1E1E"/>
+                </a:solidFill>
+                <a:latin typeface="Segoe UI"/>
+              </a:defRPr>
+            </a:pPr>
+            <a:r>
+              <a:t>■  Arsitektur Jembatan: Pertukaran Pesan Dua Arah JS ↔ Java/Kotlin via JSON-RPC.</a:t>
+            </a:r>
+          </a:p>
+          <a:p>
+            <a:pPr>
+              <a:spcAft>
+                <a:spcPts val="400"/>
+              </a:spcAft>
+              <a:defRPr sz="950">
+                <a:solidFill>
+                  <a:srgbClr val="1E1E1E"/>
+                </a:solidFill>
+                <a:latin typeface="Segoe UI"/>
+              </a:defRPr>
+            </a:pPr>
+            <a:r>
+              <a:t>■  Source-First Android: Menguasai Struktur Folder android/ &amp; Konfigurasi Gradle.</a:t>
+            </a:r>
+          </a:p>
+          <a:p>
+            <a:pPr>
+              <a:spcAft>
+                <a:spcPts val="400"/>
+              </a:spcAft>
+              <a:defRPr sz="950">
+                <a:solidFill>
+                  <a:srgbClr val="1E1E1E"/>
+                </a:solidFill>
+                <a:latin typeface="Segoe UI"/>
+              </a:defRPr>
+            </a:pPr>
+            <a:r>
+              <a:t>■  Solusi RAM 4–8GB: Pengujian Hemat Memori di HP Fisik via USB Debugging &amp; scrcpy.</a:t>
+            </a:r>
+          </a:p>
+        </p:txBody>
+      </p:sp>
+      <p:sp>
+        <p:nvSpPr>
+          <p:cNvPr id="9" name="Rectangle 8"/>
+          <p:cNvSpPr/>
+          <p:nvPr/>
+        </p:nvSpPr>
+        <p:spPr>
+          <a:xfrm>
+            <a:off x="6302959" y="2130552"/>
+            <a:ext cx="4864608" cy="2468880"/>
+          </a:xfrm>
+          <a:prstGeom prst="rect">
+            <a:avLst/>
+          </a:prstGeom>
+          <a:solidFill>
+            <a:srgbClr val="000000"/>
+          </a:solidFill>
+          <a:ln>
+            <a:noFill/>
+          </a:ln>
+        </p:spPr>
+        <p:style>
+          <a:lnRef idx="1">
+            <a:schemeClr val="accent1"/>
+          </a:lnRef>
+          <a:fillRef idx="3">
+            <a:schemeClr val="accent1"/>
+          </a:fillRef>
+          <a:effectRef idx="2">
+            <a:schemeClr val="accent1"/>
+          </a:effectRef>
+          <a:fontRef idx="minor">
+            <a:schemeClr val="lt1"/>
+          </a:fontRef>
+        </p:style>
+        <p:txBody>
+          <a:bodyPr rtlCol="0" anchor="ctr"/>
+          <a:lstStyle/>
+          <a:p>
+            <a:pPr algn="ctr"/>
+          </a:p>
+        </p:txBody>
+      </p:sp>
+      <p:sp>
+        <p:nvSpPr>
+          <p:cNvPr id="10" name="Rectangle 9"/>
+          <p:cNvSpPr/>
+          <p:nvPr/>
+        </p:nvSpPr>
+        <p:spPr>
+          <a:xfrm>
+            <a:off x="6229807" y="2057400"/>
+            <a:ext cx="4864608" cy="2468880"/>
+          </a:xfrm>
+          <a:prstGeom prst="rect">
+            <a:avLst/>
+          </a:prstGeom>
+          <a:solidFill>
+            <a:srgbClr val="FEF3C7"/>
+          </a:solidFill>
+          <a:ln w="31750">
+            <a:solidFill>
+              <a:srgbClr val="000000"/>
+            </a:solidFill>
+          </a:ln>
+        </p:spPr>
+        <p:style>
+          <a:lnRef idx="1">
+            <a:schemeClr val="accent1"/>
+          </a:lnRef>
+          <a:fillRef idx="3">
+            <a:schemeClr val="accent1"/>
+          </a:fillRef>
+          <a:effectRef idx="2">
+            <a:schemeClr val="accent1"/>
+          </a:effectRef>
+          <a:fontRef idx="minor">
+            <a:schemeClr val="lt1"/>
+          </a:fontRef>
+        </p:style>
+        <p:txBody>
+          <a:bodyPr rtlCol="0" anchor="ctr"/>
+          <a:lstStyle/>
+          <a:p>
+            <a:pPr algn="ctr"/>
+          </a:p>
+        </p:txBody>
+      </p:sp>
+      <p:sp>
+        <p:nvSpPr>
+          <p:cNvPr id="11" name="TextBox 10"/>
+          <p:cNvSpPr txBox="1"/>
+          <p:nvPr/>
+        </p:nvSpPr>
+        <p:spPr>
+          <a:xfrm>
+            <a:off x="6412687" y="2194560"/>
+            <a:ext cx="4498848" cy="2194560"/>
+          </a:xfrm>
+          <a:prstGeom prst="rect">
+            <a:avLst/>
+          </a:prstGeom>
+          <a:noFill/>
+        </p:spPr>
+        <p:txBody>
+          <a:bodyPr wrap="square">
+            <a:spAutoFit/>
+          </a:bodyPr>
+          <a:lstStyle/>
+          <a:p>
+            <a:pPr>
+              <a:spcAft>
+                <a:spcPts val="600"/>
+              </a:spcAft>
+              <a:defRPr sz="1100" b="1">
+                <a:solidFill>
+                  <a:srgbClr val="92400E"/>
+                </a:solidFill>
+                <a:latin typeface="Segoe UI"/>
+              </a:defRPr>
+            </a:pPr>
+            <a:r>
+              <a:t>📱 FOKUS SESI 06: BRIDGE &amp; ANDROID STUDIO</a:t>
+            </a:r>
+          </a:p>
+          <a:p>
+            <a:pPr>
+              <a:spcAft>
+                <a:spcPts val="400"/>
+              </a:spcAft>
+              <a:defRPr sz="950">
+                <a:solidFill>
+                  <a:srgbClr val="1E1E1E"/>
+                </a:solidFill>
+                <a:latin typeface="Segoe UI"/>
+              </a:defRPr>
+            </a:pPr>
+            <a:r>
+              <a:t>■  Sentralisasi Konfigurasi: Validasi Reverse-Domain pada capacitor.config.ts.</a:t>
+            </a:r>
+          </a:p>
+          <a:p>
+            <a:pPr>
+              <a:spcAft>
+                <a:spcPts val="400"/>
+              </a:spcAft>
+              <a:defRPr sz="950">
+                <a:solidFill>
+                  <a:srgbClr val="1E1E1E"/>
+                </a:solidFill>
+                <a:latin typeface="Segoe UI"/>
+              </a:defRPr>
+            </a:pPr>
+            <a:r>
+              <a:t>■  Alur 4 Perintah Kunci: npm run build, cap add android, cap sync, cap open.</a:t>
+            </a:r>
+          </a:p>
+          <a:p>
+            <a:pPr>
+              <a:spcAft>
+                <a:spcPts val="400"/>
+              </a:spcAft>
+              <a:defRPr sz="950">
+                <a:solidFill>
+                  <a:srgbClr val="1E1E1E"/>
+                </a:solidFill>
+                <a:latin typeface="Segoe UI"/>
+              </a:defRPr>
+            </a:pPr>
+            <a:r>
+              <a:t>■  Kontrak Sistem: AndroidManifest.xml &amp; Penanganan Runtime Permissions.</a:t>
+            </a:r>
+          </a:p>
+          <a:p>
+            <a:pPr>
+              <a:spcAft>
+                <a:spcPts val="400"/>
+              </a:spcAft>
+              <a:defRPr sz="950">
+                <a:solidFill>
+                  <a:srgbClr val="1E1E1E"/>
+                </a:solidFill>
+                <a:latin typeface="Segoe UI"/>
+              </a:defRPr>
+            </a:pPr>
+            <a:r>
+              <a:t>■  Diagnostik Lapangan: chrome://inspect WebView &amp; Cheatsheet 6 Eror Gradle.</a:t>
+            </a:r>
+          </a:p>
+        </p:txBody>
+      </p:sp>
+      <p:sp>
+        <p:nvSpPr>
+          <p:cNvPr id="12" name="Rectangle 11"/>
+          <p:cNvSpPr/>
+          <p:nvPr/>
+        </p:nvSpPr>
+        <p:spPr>
+          <a:xfrm>
+            <a:off x="1133856" y="4745736"/>
+            <a:ext cx="9997135" cy="621792"/>
+          </a:xfrm>
+          <a:prstGeom prst="rect">
+            <a:avLst/>
+          </a:prstGeom>
+          <a:solidFill>
+            <a:srgbClr val="000000"/>
+          </a:solidFill>
+          <a:ln>
+            <a:noFill/>
+          </a:ln>
+        </p:spPr>
+        <p:style>
+          <a:lnRef idx="1">
+            <a:schemeClr val="accent1"/>
+          </a:lnRef>
+          <a:fillRef idx="3">
+            <a:schemeClr val="accent1"/>
+          </a:fillRef>
+          <a:effectRef idx="2">
+            <a:schemeClr val="accent1"/>
+          </a:effectRef>
+          <a:fontRef idx="minor">
+            <a:schemeClr val="lt1"/>
+          </a:fontRef>
+        </p:style>
+        <p:txBody>
+          <a:bodyPr rtlCol="0" anchor="ctr"/>
+          <a:lstStyle/>
+          <a:p>
+            <a:pPr algn="ctr"/>
+          </a:p>
+        </p:txBody>
+      </p:sp>
+      <p:sp>
+        <p:nvSpPr>
+          <p:cNvPr id="13" name="Rectangle 12">
+            <a:hlinkClick r:id="rId2"/>
+          </p:cNvPr>
+          <p:cNvSpPr/>
+          <p:nvPr/>
+        </p:nvSpPr>
+        <p:spPr>
+          <a:xfrm>
+            <a:off x="1097280" y="4709160"/>
+            <a:ext cx="9997135" cy="621792"/>
+          </a:xfrm>
+          <a:prstGeom prst="rect">
+            <a:avLst/>
+          </a:prstGeom>
+          <a:solidFill>
+            <a:srgbClr val="FFE600"/>
+          </a:solidFill>
+          <a:ln w="25400">
+            <a:solidFill>
+              <a:srgbClr val="000000"/>
+            </a:solidFill>
+          </a:ln>
+        </p:spPr>
+        <p:style>
+          <a:lnRef idx="1">
+            <a:schemeClr val="accent1"/>
+          </a:lnRef>
+          <a:fillRef idx="3">
+            <a:schemeClr val="accent1"/>
+          </a:fillRef>
+          <a:effectRef idx="2">
+            <a:schemeClr val="accent1"/>
+          </a:effectRef>
+          <a:fontRef idx="minor">
+            <a:schemeClr val="lt1"/>
+          </a:fontRef>
+        </p:style>
+        <p:txBody>
+          <a:bodyPr rtlCol="0" anchor="ctr"/>
+          <a:lstStyle/>
+          <a:p>
+            <a:pPr algn="ctr"/>
+          </a:p>
+        </p:txBody>
+      </p:sp>
+      <p:sp>
+        <p:nvSpPr>
+          <p:cNvPr id="14" name="TextBox 13"/>
+          <p:cNvSpPr txBox="1"/>
+          <p:nvPr/>
+        </p:nvSpPr>
+        <p:spPr>
+          <a:xfrm>
+            <a:off x="1188720" y="4745736"/>
+            <a:ext cx="9814255" cy="548640"/>
+          </a:xfrm>
+          <a:prstGeom prst="rect">
+            <a:avLst/>
+          </a:prstGeom>
+          <a:noFill/>
+        </p:spPr>
+        <p:txBody>
+          <a:bodyPr wrap="square">
+            <a:spAutoFit/>
+          </a:bodyPr>
+          <a:lstStyle/>
+          <a:p>
+            <a:pPr>
+              <a:spcAft>
+                <a:spcPts val="200"/>
+              </a:spcAft>
+              <a:defRPr sz="1000" b="1">
+                <a:solidFill>
+                  <a:srgbClr val="000000"/>
+                </a:solidFill>
+                <a:latin typeface="Segoe UI"/>
+              </a:defRPr>
+            </a:pPr>
+            <a:r>
+              <a:t>▶ KLIK DI SINI UNTUK MEMBUKA BERKAS INTERAKTIF ORIENTASI SESI 06 (slide_01_orientasi_sesi_06_bridge.html)</a:t>
+            </a:r>
+          </a:p>
+          <a:p>
+            <a:pPr>
+              <a:defRPr sz="750">
                 <a:solidFill>
                   <a:srgbClr val="3C3C3C"/>
                 </a:solidFill>
-                <a:latin typeface="Segoe UI"/>
-              </a:defRPr>
-            </a:pPr>
-            <a:r>
-              <a:t>Mata Kuliah: Pemrograman Berbasis Perangkat Bergerak (STSI4303 / MSIM4401)</a:t>
-            </a:r>
-            <a:br/>
-            <a:r>
-              <a:t>Modul Acuan BMP: Modul 6 &amp; 7 • Arsitektur Jembatan, Konfigurasi Gradle, Runtime Permissions &amp; Solusi RAM 4–8GB</a:t>
-            </a:r>
-          </a:p>
-          <a:p>
-            <a:pPr>
-              <a:defRPr sz="1150" b="1">
-                <a:solidFill>
-                  <a:srgbClr val="000000"/>
-                </a:solidFill>
-                <a:latin typeface="Segoe UI"/>
-              </a:defRPr>
-            </a:pPr>
-            <a:r>
-              <a:t>■  Anton Prafanto, S.Kom., M.T.  ■  FAKULTAS SAINS DAN TEKNOLOGI • UNIVERSITAS TERBUKA</a:t>
+                <a:latin typeface="Consolas"/>
+              </a:defRPr>
+            </a:pPr>
+            <a:r>
+              <a:t>Tautan Langsung Berkas Pembelajaran: https://github.com/antonprafanto/tuweb_mobile2025/blob/main/contoh_kode_program/sesi_06_capacitor_android/slide_01_orientasi_sesi_06_bridge.html</a:t>
             </a:r>
           </a:p>
         </p:txBody>
@@ -6513,7 +7021,7 @@
               </a:defRPr>
             </a:pPr>
             <a:r>
-              <a:t>▶ KLIK UNTUK MEMBUKA BERKAS PENDUKUNG (slide_12_panduan_usb_debugging_android.md)</a:t>
+              <a:t>▶ KLIK UNTUK MEMBUKA BERKAS PENDUKUNG (slide_12_panduan_usb_debugging_android.html)</a:t>
             </a:r>
           </a:p>
         </p:txBody>
@@ -10047,7 +10555,7 @@
               </a:defRPr>
             </a:pPr>
             <a:r>
-              <a:t>▶ KLIK UNTUK MEMBUKA BERKAS PENDUKUNG (slide_16_troubleshooting_build_android.md)</a:t>
+              <a:t>▶ KLIK UNTUK MEMBUKA BERKAS PENDUKUNG (slide_16_troubleshooting_build_android.html)</a:t>
             </a:r>
           </a:p>
         </p:txBody>

</xml_diff>